<commit_message>
Final updates: Flow-GRPO training, demo fixes, training logs
</commit_message>
<xml_diff>
--- a/presentation/agentflow_slides.pptx
+++ b/presentation/agentflow_slides.pptx
@@ -13410,28 +13410,28 @@
         </p:nvSpPr>
         <p:spPr>
           <a:xfrm>
-            <a:off x="457200" y="3794760"/>
-            <a:ext cx="7406640" cy="365760"/>
-          </a:xfrm>
-          <a:prstGeom prst="rect">
-            <a:avLst/>
-          </a:prstGeom>
-          <a:noFill/>
-        </p:spPr>
-        <p:txBody>
-          <a:bodyPr wrap="square">
-            <a:spAutoFit/>
-          </a:bodyPr>
-          <a:lstStyle/>
-          <a:p>
-            <a:pPr algn="l"/>
-            <a:r>
-              <a:rPr sz="1400" b="1">
+            <a:off x="457200" y="3703320"/>
+            <a:ext cx="7406640" cy="347472"/>
+          </a:xfrm>
+          <a:prstGeom prst="rect">
+            <a:avLst/>
+          </a:prstGeom>
+          <a:noFill/>
+        </p:spPr>
+        <p:txBody>
+          <a:bodyPr wrap="square">
+            <a:spAutoFit/>
+          </a:bodyPr>
+          <a:lstStyle/>
+          <a:p>
+            <a:pPr algn="l"/>
+            <a:r>
+              <a:rPr sz="1300" b="1">
                 <a:solidFill>
                   <a:srgbClr val="1F497D"/>
                 </a:solidFill>
               </a:rPr>
-              <a:t>Qwen3.5 family (Bamboogle)</a:t>
+              <a:t>Qwen3.5 family (Modal vLLM, thinking disabled)</a:t>
             </a:r>
           </a:p>
         </p:txBody>
@@ -13444,8 +13444,8 @@
         </p:nvSpPr>
         <p:spPr>
           <a:xfrm>
-            <a:off x="320040" y="4206240"/>
-            <a:ext cx="7589520" cy="365760"/>
+            <a:off x="320040" y="4041648"/>
+            <a:ext cx="4892040" cy="347472"/>
           </a:xfrm>
           <a:prstGeom prst="rect">
             <a:avLst/>
@@ -13487,23 +13487,23 @@
         </p:nvSpPr>
         <p:spPr>
           <a:xfrm>
-            <a:off x="320040" y="4233672"/>
-            <a:ext cx="1371600" cy="320040"/>
-          </a:xfrm>
-          <a:prstGeom prst="rect">
-            <a:avLst/>
-          </a:prstGeom>
-          <a:noFill/>
-        </p:spPr>
-        <p:txBody>
-          <a:bodyPr wrap="square">
-            <a:spAutoFit/>
-          </a:bodyPr>
-          <a:lstStyle/>
-          <a:p>
-            <a:pPr algn="ctr"/>
-            <a:r>
-              <a:rPr sz="1100" b="1">
+            <a:off x="320040" y="4069080"/>
+            <a:ext cx="1143000" cy="310896"/>
+          </a:xfrm>
+          <a:prstGeom prst="rect">
+            <a:avLst/>
+          </a:prstGeom>
+          <a:noFill/>
+        </p:spPr>
+        <p:txBody>
+          <a:bodyPr wrap="square">
+            <a:spAutoFit/>
+          </a:bodyPr>
+          <a:lstStyle/>
+          <a:p>
+            <a:pPr algn="ctr"/>
+            <a:r>
+              <a:rPr sz="1000" b="1">
                 <a:solidFill>
                   <a:srgbClr val="FFFFFF"/>
                 </a:solidFill>
@@ -13521,23 +13521,23 @@
         </p:nvSpPr>
         <p:spPr>
           <a:xfrm>
-            <a:off x="1737360" y="4233672"/>
-            <a:ext cx="1188720" cy="320040"/>
-          </a:xfrm>
-          <a:prstGeom prst="rect">
-            <a:avLst/>
-          </a:prstGeom>
-          <a:noFill/>
-        </p:spPr>
-        <p:txBody>
-          <a:bodyPr wrap="square">
-            <a:spAutoFit/>
-          </a:bodyPr>
-          <a:lstStyle/>
-          <a:p>
-            <a:pPr algn="ctr"/>
-            <a:r>
-              <a:rPr sz="1100" b="1">
+            <a:off x="1600200" y="4069080"/>
+            <a:ext cx="1143000" cy="310896"/>
+          </a:xfrm>
+          <a:prstGeom prst="rect">
+            <a:avLst/>
+          </a:prstGeom>
+          <a:noFill/>
+        </p:spPr>
+        <p:txBody>
+          <a:bodyPr wrap="square">
+            <a:spAutoFit/>
+          </a:bodyPr>
+          <a:lstStyle/>
+          <a:p>
+            <a:pPr algn="ctr"/>
+            <a:r>
+              <a:rPr sz="1000" b="1">
                 <a:solidFill>
                   <a:srgbClr val="FFFFFF"/>
                 </a:solidFill>
@@ -13555,35 +13555,794 @@
         </p:nvSpPr>
         <p:spPr>
           <a:xfrm>
-            <a:off x="3017520" y="4251960"/>
-            <a:ext cx="4572000" cy="320040"/>
-          </a:xfrm>
-          <a:prstGeom prst="rect">
-            <a:avLst/>
-          </a:prstGeom>
-          <a:noFill/>
-        </p:spPr>
-        <p:txBody>
-          <a:bodyPr wrap="square">
-            <a:spAutoFit/>
-          </a:bodyPr>
-          <a:lstStyle/>
-          <a:p>
-            <a:pPr algn="l"/>
-            <a:r>
-              <a:rPr sz="1100" b="0">
-                <a:solidFill>
-                  <a:srgbClr val="999999"/>
-                </a:solidFill>
-              </a:rPr>
-              <a:t>(results pending)</a:t>
-            </a:r>
-          </a:p>
-        </p:txBody>
-      </p:sp>
-      <p:sp>
-        <p:nvSpPr>
-          <p:cNvPr id="41" name="TextBox 40"/>
+            <a:off x="2880360" y="4069080"/>
+            <a:ext cx="1143000" cy="310896"/>
+          </a:xfrm>
+          <a:prstGeom prst="rect">
+            <a:avLst/>
+          </a:prstGeom>
+          <a:noFill/>
+        </p:spPr>
+        <p:txBody>
+          <a:bodyPr wrap="square">
+            <a:spAutoFit/>
+          </a:bodyPr>
+          <a:lstStyle/>
+          <a:p>
+            <a:pPr algn="ctr"/>
+            <a:r>
+              <a:rPr sz="1000" b="1">
+                <a:solidFill>
+                  <a:srgbClr val="FFFFFF"/>
+                </a:solidFill>
+              </a:rPr>
+              <a:t>Text2sql</a:t>
+            </a:r>
+          </a:p>
+        </p:txBody>
+      </p:sp>
+      <p:sp>
+        <p:nvSpPr>
+          <p:cNvPr id="41" name="Rectangle 40"/>
+          <p:cNvSpPr/>
+          <p:nvPr/>
+        </p:nvSpPr>
+        <p:spPr>
+          <a:xfrm>
+            <a:off x="320040" y="4389120"/>
+            <a:ext cx="4892040" cy="310896"/>
+          </a:xfrm>
+          <a:prstGeom prst="rect">
+            <a:avLst/>
+          </a:prstGeom>
+          <a:solidFill>
+            <a:srgbClr val="F2F2F2"/>
+          </a:solidFill>
+          <a:ln>
+            <a:noFill/>
+          </a:ln>
+        </p:spPr>
+        <p:style>
+          <a:lnRef idx="1">
+            <a:schemeClr val="accent1"/>
+          </a:lnRef>
+          <a:fillRef idx="3">
+            <a:schemeClr val="accent1"/>
+          </a:fillRef>
+          <a:effectRef idx="2">
+            <a:schemeClr val="accent1"/>
+          </a:effectRef>
+          <a:fontRef idx="minor">
+            <a:schemeClr val="lt1"/>
+          </a:fontRef>
+        </p:style>
+        <p:txBody>
+          <a:bodyPr rtlCol="0" anchor="ctr"/>
+          <a:lstStyle/>
+          <a:p>
+            <a:pPr algn="ctr"/>
+          </a:p>
+        </p:txBody>
+      </p:sp>
+      <p:sp>
+        <p:nvSpPr>
+          <p:cNvPr id="42" name="TextBox 41"/>
+          <p:cNvSpPr txBox="1"/>
+          <p:nvPr/>
+        </p:nvSpPr>
+        <p:spPr>
+          <a:xfrm>
+            <a:off x="320040" y="4407408"/>
+            <a:ext cx="1143000" cy="292608"/>
+          </a:xfrm>
+          <a:prstGeom prst="rect">
+            <a:avLst/>
+          </a:prstGeom>
+          <a:noFill/>
+        </p:spPr>
+        <p:txBody>
+          <a:bodyPr wrap="square">
+            <a:spAutoFit/>
+          </a:bodyPr>
+          <a:lstStyle/>
+          <a:p>
+            <a:pPr algn="ctr"/>
+            <a:r>
+              <a:rPr sz="1000" b="0">
+                <a:solidFill>
+                  <a:srgbClr val="262626"/>
+                </a:solidFill>
+              </a:rPr>
+              <a:t>0.8B</a:t>
+            </a:r>
+          </a:p>
+        </p:txBody>
+      </p:sp>
+      <p:sp>
+        <p:nvSpPr>
+          <p:cNvPr id="43" name="TextBox 42"/>
+          <p:cNvSpPr txBox="1"/>
+          <p:nvPr/>
+        </p:nvSpPr>
+        <p:spPr>
+          <a:xfrm>
+            <a:off x="1600200" y="4407408"/>
+            <a:ext cx="1143000" cy="292608"/>
+          </a:xfrm>
+          <a:prstGeom prst="rect">
+            <a:avLst/>
+          </a:prstGeom>
+          <a:noFill/>
+        </p:spPr>
+        <p:txBody>
+          <a:bodyPr wrap="square">
+            <a:spAutoFit/>
+          </a:bodyPr>
+          <a:lstStyle/>
+          <a:p>
+            <a:pPr algn="ctr"/>
+            <a:r>
+              <a:rPr sz="1000" b="0">
+                <a:solidFill>
+                  <a:srgbClr val="262626"/>
+                </a:solidFill>
+              </a:rPr>
+              <a:t>36.0%</a:t>
+            </a:r>
+          </a:p>
+        </p:txBody>
+      </p:sp>
+      <p:sp>
+        <p:nvSpPr>
+          <p:cNvPr id="44" name="TextBox 43"/>
+          <p:cNvSpPr txBox="1"/>
+          <p:nvPr/>
+        </p:nvSpPr>
+        <p:spPr>
+          <a:xfrm>
+            <a:off x="2880360" y="4407408"/>
+            <a:ext cx="1143000" cy="292608"/>
+          </a:xfrm>
+          <a:prstGeom prst="rect">
+            <a:avLst/>
+          </a:prstGeom>
+          <a:noFill/>
+        </p:spPr>
+        <p:txBody>
+          <a:bodyPr wrap="square">
+            <a:spAutoFit/>
+          </a:bodyPr>
+          <a:lstStyle/>
+          <a:p>
+            <a:pPr algn="ctr"/>
+            <a:r>
+              <a:rPr sz="1000" b="0">
+                <a:solidFill>
+                  <a:srgbClr val="262626"/>
+                </a:solidFill>
+              </a:rPr>
+              <a:t>93.6%</a:t>
+            </a:r>
+          </a:p>
+        </p:txBody>
+      </p:sp>
+      <p:sp>
+        <p:nvSpPr>
+          <p:cNvPr id="45" name="Rectangle 44"/>
+          <p:cNvSpPr/>
+          <p:nvPr/>
+        </p:nvSpPr>
+        <p:spPr>
+          <a:xfrm>
+            <a:off x="320040" y="4700016"/>
+            <a:ext cx="4892040" cy="310896"/>
+          </a:xfrm>
+          <a:prstGeom prst="rect">
+            <a:avLst/>
+          </a:prstGeom>
+          <a:solidFill>
+            <a:srgbClr val="FFFFFF"/>
+          </a:solidFill>
+          <a:ln>
+            <a:noFill/>
+          </a:ln>
+        </p:spPr>
+        <p:style>
+          <a:lnRef idx="1">
+            <a:schemeClr val="accent1"/>
+          </a:lnRef>
+          <a:fillRef idx="3">
+            <a:schemeClr val="accent1"/>
+          </a:fillRef>
+          <a:effectRef idx="2">
+            <a:schemeClr val="accent1"/>
+          </a:effectRef>
+          <a:fontRef idx="minor">
+            <a:schemeClr val="lt1"/>
+          </a:fontRef>
+        </p:style>
+        <p:txBody>
+          <a:bodyPr rtlCol="0" anchor="ctr"/>
+          <a:lstStyle/>
+          <a:p>
+            <a:pPr algn="ctr"/>
+          </a:p>
+        </p:txBody>
+      </p:sp>
+      <p:sp>
+        <p:nvSpPr>
+          <p:cNvPr id="46" name="TextBox 45"/>
+          <p:cNvSpPr txBox="1"/>
+          <p:nvPr/>
+        </p:nvSpPr>
+        <p:spPr>
+          <a:xfrm>
+            <a:off x="320040" y="4718304"/>
+            <a:ext cx="1143000" cy="292608"/>
+          </a:xfrm>
+          <a:prstGeom prst="rect">
+            <a:avLst/>
+          </a:prstGeom>
+          <a:noFill/>
+        </p:spPr>
+        <p:txBody>
+          <a:bodyPr wrap="square">
+            <a:spAutoFit/>
+          </a:bodyPr>
+          <a:lstStyle/>
+          <a:p>
+            <a:pPr algn="ctr"/>
+            <a:r>
+              <a:rPr sz="1000" b="0">
+                <a:solidFill>
+                  <a:srgbClr val="262626"/>
+                </a:solidFill>
+              </a:rPr>
+              <a:t>2B</a:t>
+            </a:r>
+          </a:p>
+        </p:txBody>
+      </p:sp>
+      <p:sp>
+        <p:nvSpPr>
+          <p:cNvPr id="47" name="TextBox 46"/>
+          <p:cNvSpPr txBox="1"/>
+          <p:nvPr/>
+        </p:nvSpPr>
+        <p:spPr>
+          <a:xfrm>
+            <a:off x="1600200" y="4718304"/>
+            <a:ext cx="1143000" cy="292608"/>
+          </a:xfrm>
+          <a:prstGeom prst="rect">
+            <a:avLst/>
+          </a:prstGeom>
+          <a:noFill/>
+        </p:spPr>
+        <p:txBody>
+          <a:bodyPr wrap="square">
+            <a:spAutoFit/>
+          </a:bodyPr>
+          <a:lstStyle/>
+          <a:p>
+            <a:pPr algn="ctr"/>
+            <a:r>
+              <a:rPr sz="1000" b="1">
+                <a:solidFill>
+                  <a:srgbClr val="ED7D31"/>
+                </a:solidFill>
+              </a:rPr>
+              <a:t>49.6%</a:t>
+            </a:r>
+          </a:p>
+        </p:txBody>
+      </p:sp>
+      <p:sp>
+        <p:nvSpPr>
+          <p:cNvPr id="48" name="TextBox 47"/>
+          <p:cNvSpPr txBox="1"/>
+          <p:nvPr/>
+        </p:nvSpPr>
+        <p:spPr>
+          <a:xfrm>
+            <a:off x="2880360" y="4718304"/>
+            <a:ext cx="1143000" cy="292608"/>
+          </a:xfrm>
+          <a:prstGeom prst="rect">
+            <a:avLst/>
+          </a:prstGeom>
+          <a:noFill/>
+        </p:spPr>
+        <p:txBody>
+          <a:bodyPr wrap="square">
+            <a:spAutoFit/>
+          </a:bodyPr>
+          <a:lstStyle/>
+          <a:p>
+            <a:pPr algn="ctr"/>
+            <a:r>
+              <a:rPr sz="1000" b="0">
+                <a:solidFill>
+                  <a:srgbClr val="262626"/>
+                </a:solidFill>
+              </a:rPr>
+              <a:t>91.8%</a:t>
+            </a:r>
+          </a:p>
+        </p:txBody>
+      </p:sp>
+      <p:sp>
+        <p:nvSpPr>
+          <p:cNvPr id="49" name="Rectangle 48"/>
+          <p:cNvSpPr/>
+          <p:nvPr/>
+        </p:nvSpPr>
+        <p:spPr>
+          <a:xfrm>
+            <a:off x="320040" y="5010912"/>
+            <a:ext cx="4892040" cy="310896"/>
+          </a:xfrm>
+          <a:prstGeom prst="rect">
+            <a:avLst/>
+          </a:prstGeom>
+          <a:solidFill>
+            <a:srgbClr val="F2F2F2"/>
+          </a:solidFill>
+          <a:ln>
+            <a:noFill/>
+          </a:ln>
+        </p:spPr>
+        <p:style>
+          <a:lnRef idx="1">
+            <a:schemeClr val="accent1"/>
+          </a:lnRef>
+          <a:fillRef idx="3">
+            <a:schemeClr val="accent1"/>
+          </a:fillRef>
+          <a:effectRef idx="2">
+            <a:schemeClr val="accent1"/>
+          </a:effectRef>
+          <a:fontRef idx="minor">
+            <a:schemeClr val="lt1"/>
+          </a:fontRef>
+        </p:style>
+        <p:txBody>
+          <a:bodyPr rtlCol="0" anchor="ctr"/>
+          <a:lstStyle/>
+          <a:p>
+            <a:pPr algn="ctr"/>
+          </a:p>
+        </p:txBody>
+      </p:sp>
+      <p:sp>
+        <p:nvSpPr>
+          <p:cNvPr id="50" name="TextBox 49"/>
+          <p:cNvSpPr txBox="1"/>
+          <p:nvPr/>
+        </p:nvSpPr>
+        <p:spPr>
+          <a:xfrm>
+            <a:off x="320040" y="5029200"/>
+            <a:ext cx="1143000" cy="292608"/>
+          </a:xfrm>
+          <a:prstGeom prst="rect">
+            <a:avLst/>
+          </a:prstGeom>
+          <a:noFill/>
+        </p:spPr>
+        <p:txBody>
+          <a:bodyPr wrap="square">
+            <a:spAutoFit/>
+          </a:bodyPr>
+          <a:lstStyle/>
+          <a:p>
+            <a:pPr algn="ctr"/>
+            <a:r>
+              <a:rPr sz="1000" b="0">
+                <a:solidFill>
+                  <a:srgbClr val="262626"/>
+                </a:solidFill>
+              </a:rPr>
+              <a:t>4B</a:t>
+            </a:r>
+          </a:p>
+        </p:txBody>
+      </p:sp>
+      <p:sp>
+        <p:nvSpPr>
+          <p:cNvPr id="51" name="TextBox 50"/>
+          <p:cNvSpPr txBox="1"/>
+          <p:nvPr/>
+        </p:nvSpPr>
+        <p:spPr>
+          <a:xfrm>
+            <a:off x="1600200" y="5029200"/>
+            <a:ext cx="1143000" cy="292608"/>
+          </a:xfrm>
+          <a:prstGeom prst="rect">
+            <a:avLst/>
+          </a:prstGeom>
+          <a:noFill/>
+        </p:spPr>
+        <p:txBody>
+          <a:bodyPr wrap="square">
+            <a:spAutoFit/>
+          </a:bodyPr>
+          <a:lstStyle/>
+          <a:p>
+            <a:pPr algn="ctr"/>
+            <a:r>
+              <a:rPr sz="1000" b="1">
+                <a:solidFill>
+                  <a:srgbClr val="ED7D31"/>
+                </a:solidFill>
+              </a:rPr>
+              <a:t>49.6%</a:t>
+            </a:r>
+          </a:p>
+        </p:txBody>
+      </p:sp>
+      <p:sp>
+        <p:nvSpPr>
+          <p:cNvPr id="52" name="TextBox 51"/>
+          <p:cNvSpPr txBox="1"/>
+          <p:nvPr/>
+        </p:nvSpPr>
+        <p:spPr>
+          <a:xfrm>
+            <a:off x="2880360" y="5029200"/>
+            <a:ext cx="1143000" cy="292608"/>
+          </a:xfrm>
+          <a:prstGeom prst="rect">
+            <a:avLst/>
+          </a:prstGeom>
+          <a:noFill/>
+        </p:spPr>
+        <p:txBody>
+          <a:bodyPr wrap="square">
+            <a:spAutoFit/>
+          </a:bodyPr>
+          <a:lstStyle/>
+          <a:p>
+            <a:pPr algn="ctr"/>
+            <a:r>
+              <a:rPr sz="1000" b="1">
+                <a:solidFill>
+                  <a:srgbClr val="ED7D31"/>
+                </a:solidFill>
+              </a:rPr>
+              <a:t>94.3%</a:t>
+            </a:r>
+          </a:p>
+        </p:txBody>
+      </p:sp>
+      <p:sp>
+        <p:nvSpPr>
+          <p:cNvPr id="53" name="Rectangle 52"/>
+          <p:cNvSpPr/>
+          <p:nvPr/>
+        </p:nvSpPr>
+        <p:spPr>
+          <a:xfrm>
+            <a:off x="320040" y="5321808"/>
+            <a:ext cx="4892040" cy="310896"/>
+          </a:xfrm>
+          <a:prstGeom prst="rect">
+            <a:avLst/>
+          </a:prstGeom>
+          <a:solidFill>
+            <a:srgbClr val="FFFFFF"/>
+          </a:solidFill>
+          <a:ln>
+            <a:noFill/>
+          </a:ln>
+        </p:spPr>
+        <p:style>
+          <a:lnRef idx="1">
+            <a:schemeClr val="accent1"/>
+          </a:lnRef>
+          <a:fillRef idx="3">
+            <a:schemeClr val="accent1"/>
+          </a:fillRef>
+          <a:effectRef idx="2">
+            <a:schemeClr val="accent1"/>
+          </a:effectRef>
+          <a:fontRef idx="minor">
+            <a:schemeClr val="lt1"/>
+          </a:fontRef>
+        </p:style>
+        <p:txBody>
+          <a:bodyPr rtlCol="0" anchor="ctr"/>
+          <a:lstStyle/>
+          <a:p>
+            <a:pPr algn="ctr"/>
+          </a:p>
+        </p:txBody>
+      </p:sp>
+      <p:sp>
+        <p:nvSpPr>
+          <p:cNvPr id="54" name="TextBox 53"/>
+          <p:cNvSpPr txBox="1"/>
+          <p:nvPr/>
+        </p:nvSpPr>
+        <p:spPr>
+          <a:xfrm>
+            <a:off x="320040" y="5340096"/>
+            <a:ext cx="1143000" cy="292608"/>
+          </a:xfrm>
+          <a:prstGeom prst="rect">
+            <a:avLst/>
+          </a:prstGeom>
+          <a:noFill/>
+        </p:spPr>
+        <p:txBody>
+          <a:bodyPr wrap="square">
+            <a:spAutoFit/>
+          </a:bodyPr>
+          <a:lstStyle/>
+          <a:p>
+            <a:pPr algn="ctr"/>
+            <a:r>
+              <a:rPr sz="1000" b="0">
+                <a:solidFill>
+                  <a:srgbClr val="262626"/>
+                </a:solidFill>
+              </a:rPr>
+              <a:t>9B</a:t>
+            </a:r>
+          </a:p>
+        </p:txBody>
+      </p:sp>
+      <p:sp>
+        <p:nvSpPr>
+          <p:cNvPr id="55" name="TextBox 54"/>
+          <p:cNvSpPr txBox="1"/>
+          <p:nvPr/>
+        </p:nvSpPr>
+        <p:spPr>
+          <a:xfrm>
+            <a:off x="1600200" y="5340096"/>
+            <a:ext cx="1143000" cy="292608"/>
+          </a:xfrm>
+          <a:prstGeom prst="rect">
+            <a:avLst/>
+          </a:prstGeom>
+          <a:noFill/>
+        </p:spPr>
+        <p:txBody>
+          <a:bodyPr wrap="square">
+            <a:spAutoFit/>
+          </a:bodyPr>
+          <a:lstStyle/>
+          <a:p>
+            <a:pPr algn="ctr"/>
+            <a:r>
+              <a:rPr sz="1000" b="0">
+                <a:solidFill>
+                  <a:srgbClr val="262626"/>
+                </a:solidFill>
+              </a:rPr>
+              <a:t>40.0%</a:t>
+            </a:r>
+          </a:p>
+        </p:txBody>
+      </p:sp>
+      <p:sp>
+        <p:nvSpPr>
+          <p:cNvPr id="56" name="TextBox 55"/>
+          <p:cNvSpPr txBox="1"/>
+          <p:nvPr/>
+        </p:nvSpPr>
+        <p:spPr>
+          <a:xfrm>
+            <a:off x="2880360" y="5340096"/>
+            <a:ext cx="1143000" cy="292608"/>
+          </a:xfrm>
+          <a:prstGeom prst="rect">
+            <a:avLst/>
+          </a:prstGeom>
+          <a:noFill/>
+        </p:spPr>
+        <p:txBody>
+          <a:bodyPr wrap="square">
+            <a:spAutoFit/>
+          </a:bodyPr>
+          <a:lstStyle/>
+          <a:p>
+            <a:pPr algn="ctr"/>
+            <a:r>
+              <a:rPr sz="1000" b="0">
+                <a:solidFill>
+                  <a:srgbClr val="262626"/>
+                </a:solidFill>
+              </a:rPr>
+              <a:t>93.7%</a:t>
+            </a:r>
+          </a:p>
+        </p:txBody>
+      </p:sp>
+      <p:sp>
+        <p:nvSpPr>
+          <p:cNvPr id="57" name="Rectangle 56"/>
+          <p:cNvSpPr/>
+          <p:nvPr/>
+        </p:nvSpPr>
+        <p:spPr>
+          <a:xfrm>
+            <a:off x="320040" y="5632704"/>
+            <a:ext cx="4892040" cy="310896"/>
+          </a:xfrm>
+          <a:prstGeom prst="rect">
+            <a:avLst/>
+          </a:prstGeom>
+          <a:solidFill>
+            <a:srgbClr val="F2F2F2"/>
+          </a:solidFill>
+          <a:ln>
+            <a:noFill/>
+          </a:ln>
+        </p:spPr>
+        <p:style>
+          <a:lnRef idx="1">
+            <a:schemeClr val="accent1"/>
+          </a:lnRef>
+          <a:fillRef idx="3">
+            <a:schemeClr val="accent1"/>
+          </a:fillRef>
+          <a:effectRef idx="2">
+            <a:schemeClr val="accent1"/>
+          </a:effectRef>
+          <a:fontRef idx="minor">
+            <a:schemeClr val="lt1"/>
+          </a:fontRef>
+        </p:style>
+        <p:txBody>
+          <a:bodyPr rtlCol="0" anchor="ctr"/>
+          <a:lstStyle/>
+          <a:p>
+            <a:pPr algn="ctr"/>
+          </a:p>
+        </p:txBody>
+      </p:sp>
+      <p:sp>
+        <p:nvSpPr>
+          <p:cNvPr id="58" name="TextBox 57"/>
+          <p:cNvSpPr txBox="1"/>
+          <p:nvPr/>
+        </p:nvSpPr>
+        <p:spPr>
+          <a:xfrm>
+            <a:off x="320040" y="5650992"/>
+            <a:ext cx="1143000" cy="292608"/>
+          </a:xfrm>
+          <a:prstGeom prst="rect">
+            <a:avLst/>
+          </a:prstGeom>
+          <a:noFill/>
+        </p:spPr>
+        <p:txBody>
+          <a:bodyPr wrap="square">
+            <a:spAutoFit/>
+          </a:bodyPr>
+          <a:lstStyle/>
+          <a:p>
+            <a:pPr algn="ctr"/>
+            <a:r>
+              <a:rPr sz="1000" b="0">
+                <a:solidFill>
+                  <a:srgbClr val="262626"/>
+                </a:solidFill>
+              </a:rPr>
+              <a:t>27B</a:t>
+            </a:r>
+          </a:p>
+        </p:txBody>
+      </p:sp>
+      <p:sp>
+        <p:nvSpPr>
+          <p:cNvPr id="59" name="TextBox 58"/>
+          <p:cNvSpPr txBox="1"/>
+          <p:nvPr/>
+        </p:nvSpPr>
+        <p:spPr>
+          <a:xfrm>
+            <a:off x="1600200" y="5650992"/>
+            <a:ext cx="1143000" cy="292608"/>
+          </a:xfrm>
+          <a:prstGeom prst="rect">
+            <a:avLst/>
+          </a:prstGeom>
+          <a:noFill/>
+        </p:spPr>
+        <p:txBody>
+          <a:bodyPr wrap="square">
+            <a:spAutoFit/>
+          </a:bodyPr>
+          <a:lstStyle/>
+          <a:p>
+            <a:pPr algn="ctr"/>
+            <a:r>
+              <a:rPr sz="1000" b="0">
+                <a:solidFill>
+                  <a:srgbClr val="262626"/>
+                </a:solidFill>
+              </a:rPr>
+              <a:t>~31%</a:t>
+            </a:r>
+          </a:p>
+        </p:txBody>
+      </p:sp>
+      <p:sp>
+        <p:nvSpPr>
+          <p:cNvPr id="60" name="TextBox 59"/>
+          <p:cNvSpPr txBox="1"/>
+          <p:nvPr/>
+        </p:nvSpPr>
+        <p:spPr>
+          <a:xfrm>
+            <a:off x="2880360" y="5650992"/>
+            <a:ext cx="1143000" cy="292608"/>
+          </a:xfrm>
+          <a:prstGeom prst="rect">
+            <a:avLst/>
+          </a:prstGeom>
+          <a:noFill/>
+        </p:spPr>
+        <p:txBody>
+          <a:bodyPr wrap="square">
+            <a:spAutoFit/>
+          </a:bodyPr>
+          <a:lstStyle/>
+          <a:p>
+            <a:pPr algn="ctr"/>
+            <a:r>
+              <a:rPr sz="1000" b="0">
+                <a:solidFill>
+                  <a:srgbClr val="262626"/>
+                </a:solidFill>
+              </a:rPr>
+              <a:t>—</a:t>
+            </a:r>
+          </a:p>
+        </p:txBody>
+      </p:sp>
+      <p:sp>
+        <p:nvSpPr>
+          <p:cNvPr id="61" name="TextBox 60"/>
+          <p:cNvSpPr txBox="1"/>
+          <p:nvPr/>
+        </p:nvSpPr>
+        <p:spPr>
+          <a:xfrm>
+            <a:off x="320040" y="5989320"/>
+            <a:ext cx="7498079" cy="411480"/>
+          </a:xfrm>
+          <a:prstGeom prst="rect">
+            <a:avLst/>
+          </a:prstGeom>
+          <a:noFill/>
+        </p:spPr>
+        <p:txBody>
+          <a:bodyPr wrap="square">
+            <a:spAutoFit/>
+          </a:bodyPr>
+          <a:lstStyle/>
+          <a:p>
+            <a:pPr algn="l"/>
+            <a:r>
+              <a:rPr sz="900" b="0">
+                <a:solidFill>
+                  <a:srgbClr val="262626"/>
+                </a:solidFill>
+              </a:rPr>
+              <a:t>*27B: sampled subset; 2B/4B sweet spot on Bamboogle; verbose 9B/27B hurts tool JSON matching.</a:t>
+            </a:r>
+          </a:p>
+        </p:txBody>
+      </p:sp>
+      <p:sp>
+        <p:nvSpPr>
+          <p:cNvPr id="62" name="TextBox 61"/>
           <p:cNvSpPr txBox="1"/>
           <p:nvPr/>
         </p:nvSpPr>
@@ -13617,7 +14376,7 @@
       </p:sp>
       <p:sp>
         <p:nvSpPr>
-          <p:cNvPr id="42" name="TextBox 41"/>
+          <p:cNvPr id="63" name="TextBox 62"/>
           <p:cNvSpPr txBox="1"/>
           <p:nvPr/>
         </p:nvSpPr>
@@ -13652,7 +14411,7 @@
       </p:sp>
       <p:sp>
         <p:nvSpPr>
-          <p:cNvPr id="43" name="TextBox 42"/>
+          <p:cNvPr id="64" name="TextBox 63"/>
           <p:cNvSpPr txBox="1"/>
           <p:nvPr/>
         </p:nvSpPr>
@@ -13687,7 +14446,7 @@
       </p:sp>
       <p:sp>
         <p:nvSpPr>
-          <p:cNvPr id="44" name="TextBox 43"/>
+          <p:cNvPr id="65" name="TextBox 64"/>
           <p:cNvSpPr txBox="1"/>
           <p:nvPr/>
         </p:nvSpPr>
@@ -13722,7 +14481,7 @@
       </p:sp>
       <p:sp>
         <p:nvSpPr>
-          <p:cNvPr id="45" name="TextBox 44"/>
+          <p:cNvPr id="66" name="TextBox 65"/>
           <p:cNvSpPr txBox="1"/>
           <p:nvPr/>
         </p:nvSpPr>
@@ -13758,7 +14517,7 @@
       </p:sp>
       <p:sp>
         <p:nvSpPr>
-          <p:cNvPr id="46" name="TextBox 45"/>
+          <p:cNvPr id="67" name="TextBox 66"/>
           <p:cNvSpPr txBox="1"/>
           <p:nvPr/>
         </p:nvSpPr>

</xml_diff>